<commit_message>
Add Project Monitoring II deck; update diagrams for all six modules; fix invalid pptx shape
The 20-slide deck carries the full report content updated to the finished
system, with a native architecture diagram and real UI screenshots. Diagram
sources for architecture, module design, DFDs, use case, class and ER were
rewritten from the code, and a follow-up sequence diagram added.

The Monitoring I deck (and its build script) used the shape name oval, which is
not a valid preset: PowerPoint reported the file as corrupt. Now ellipse, and
both decks open in PowerPoint.
</commit_message>
<xml_diff>
--- a/docs/DreamOS-Project-Monitoring-I.pptx
+++ b/docs/DreamOS-Project-Monitoring-I.pptx
@@ -1266,7 +1266,7 @@
             <a:off x="822960" y="914400"/>
             <a:ext cx="822960" cy="822960"/>
           </a:xfrm>
-          <a:prstGeom prst="oval">
+          <a:prstGeom prst="ellipse">
             <a:avLst/>
           </a:prstGeom>
           <a:solidFill>
@@ -1880,7 +1880,7 @@
             <a:off x="6263640" y="1874520"/>
             <a:ext cx="566928" cy="566928"/>
           </a:xfrm>
-          <a:prstGeom prst="oval">
+          <a:prstGeom prst="ellipse">
             <a:avLst/>
           </a:prstGeom>
           <a:solidFill>
@@ -2002,7 +2002,7 @@
             <a:off x="6263640" y="3044952"/>
             <a:ext cx="566928" cy="566928"/>
           </a:xfrm>
-          <a:prstGeom prst="oval">
+          <a:prstGeom prst="ellipse">
             <a:avLst/>
           </a:prstGeom>
           <a:solidFill>
@@ -2124,7 +2124,7 @@
             <a:off x="6263640" y="4215384"/>
             <a:ext cx="566928" cy="566928"/>
           </a:xfrm>
-          <a:prstGeom prst="oval">
+          <a:prstGeom prst="ellipse">
             <a:avLst/>
           </a:prstGeom>
           <a:solidFill>
@@ -2393,8 +2393,8 @@
         </p:blipFill>
         <p:spPr>
           <a:xfrm>
-            <a:off x="777240" y="1753747"/>
-            <a:ext cx="6537960" cy="3944866"/>
+            <a:off x="777240" y="1962286"/>
+            <a:ext cx="6537960" cy="3527788"/>
           </a:xfrm>
           <a:prstGeom prst="rect">
             <a:avLst/>
@@ -3891,7 +3891,7 @@
             <a:off x="640080" y="1874520"/>
             <a:ext cx="548640" cy="548640"/>
           </a:xfrm>
-          <a:prstGeom prst="oval">
+          <a:prstGeom prst="ellipse">
             <a:avLst/>
           </a:prstGeom>
           <a:solidFill>
@@ -4013,7 +4013,7 @@
             <a:off x="640080" y="2898648"/>
             <a:ext cx="548640" cy="548640"/>
           </a:xfrm>
-          <a:prstGeom prst="oval">
+          <a:prstGeom prst="ellipse">
             <a:avLst/>
           </a:prstGeom>
           <a:solidFill>
@@ -4135,7 +4135,7 @@
             <a:off x="640080" y="3922776"/>
             <a:ext cx="548640" cy="548640"/>
           </a:xfrm>
-          <a:prstGeom prst="oval">
+          <a:prstGeom prst="ellipse">
             <a:avLst/>
           </a:prstGeom>
           <a:solidFill>

</xml_diff>